<commit_message>
Add Trust Score visual slide — MarketSquare_LaunchPlan_Updated.pptx
Slide 8 illustrates the full Trust Score framework: tier ladder (0-39/40-69/70-89/90-100), three score groups (Universal 30pts, Track Record 30pts, Category Credentials 40pts), all 7 category credential rows, penalty box, and five anti-manipulation rules in footer.

Co-Authored-By: Claude Sonnet 4.6 <noreply@anthropic.com>
</commit_message>
<xml_diff>
--- a/MarketSquare_LaunchPlan_Updated.pptx
+++ b/MarketSquare_LaunchPlan_Updated.pptx
@@ -10333,7 +10333,7 @@
                 </a:solidFill>
                 <a:latin typeface="Calibri"/>
               </a:rPr>
-              <a:t>Score 80–100 · Gold Badge</a:t>
+              <a:t>Score 90–100 · Gold Badge</a:t>
             </a:r>
           </a:p>
           <a:p>
@@ -10451,7 +10451,7 @@
                 </a:solidFill>
                 <a:latin typeface="Calibri"/>
               </a:rPr>
-              <a:t>Score 60–79 · Green Badge</a:t>
+              <a:t>Score 70–89 · Green Badge</a:t>
             </a:r>
           </a:p>
           <a:p>
@@ -10569,7 +10569,7 @@
                 </a:solidFill>
                 <a:latin typeface="Calibri"/>
               </a:rPr>
-              <a:t>Score 40–59 · Blue Badge</a:t>
+              <a:t>Score 40–69 · Blue Badge</a:t>
             </a:r>
           </a:p>
           <a:p>
@@ -10925,7 +10925,7 @@
                 </a:solidFill>
                 <a:latin typeface="Calibri"/>
               </a:rPr>
-              <a:t>50 pts total · All categories</a:t>
+              <a:t>30 pts total · All categories</a:t>
             </a:r>
           </a:p>
         </p:txBody>
@@ -11332,7 +11332,7 @@
         <p:spPr>
           <a:xfrm>
             <a:off x="2834640" y="5563800"/>
-            <a:ext cx="1458792" cy="91440"/>
+            <a:ext cx="875275" cy="91440"/>
           </a:xfrm>
           <a:prstGeom prst="rect">
             <a:avLst/>
@@ -11987,7 +11987,7 @@
                 </a:solidFill>
                 <a:latin typeface="Calibri"/>
               </a:rPr>
-              <a:t>20 pts total · Per category</a:t>
+              <a:t>40 pts total · Per category</a:t>
             </a:r>
           </a:p>
         </p:txBody>
@@ -12484,7 +12484,7 @@
         <p:spPr>
           <a:xfrm>
             <a:off x="8998128" y="5563800"/>
-            <a:ext cx="593054" cy="91440"/>
+            <a:ext cx="1186109" cy="91440"/>
           </a:xfrm>
           <a:prstGeom prst="rect">
             <a:avLst/>
@@ -12626,7 +12626,7 @@
                 </a:solidFill>
                 <a:latin typeface="Calibri"/>
               </a:rPr>
-              <a:t>Score resets annually</a:t>
+              <a:t>No self-reporting</a:t>
             </a:r>
           </a:p>
           <a:p>
@@ -12637,7 +12637,7 @@
                 </a:solidFill>
                 <a:latin typeface="Calibri"/>
               </a:rPr>
-              <a:t>Keep earning each year</a:t>
+              <a:t>Docs required</a:t>
             </a:r>
           </a:p>
         </p:txBody>
@@ -12733,7 +12733,7 @@
                 </a:solidFill>
                 <a:latin typeface="Calibri"/>
               </a:rPr>
-              <a:t>Buyers have scores too</a:t>
+              <a:t>Reg numbers checked live</a:t>
             </a:r>
           </a:p>
           <a:p>
@@ -12744,7 +12744,7 @@
                 </a:solidFill>
                 <a:latin typeface="Calibri"/>
               </a:rPr>
-              <a:t>Trust is reciprocal</a:t>
+              <a:t>Real-time verification</a:t>
             </a:r>
           </a:p>
         </p:txBody>
@@ -12840,7 +12840,7 @@
                 </a:solidFill>
                 <a:latin typeface="Calibri"/>
               </a:rPr>
-              <a:t>Scores are public</a:t>
+              <a:t>Track record is system-only</a:t>
             </a:r>
           </a:p>
           <a:p>
@@ -12851,7 +12851,7 @@
                 </a:solidFill>
                 <a:latin typeface="Calibri"/>
               </a:rPr>
-              <a:t>Visible on all listings</a:t>
+              <a:t>No manual overrides</a:t>
             </a:r>
           </a:p>
         </p:txBody>
@@ -12947,7 +12947,7 @@
                 </a:solidFill>
                 <a:latin typeface="Calibri"/>
               </a:rPr>
-              <a:t>Dispute a score</a:t>
+              <a:t>Server-side score only</a:t>
             </a:r>
           </a:p>
           <a:p>
@@ -12958,7 +12958,7 @@
                 </a:solidFill>
                 <a:latin typeface="Calibri"/>
               </a:rPr>
-              <a:t>Admin reviews within 48h</a:t>
+              <a:t>Client cannot modify</a:t>
             </a:r>
           </a:p>
         </p:txBody>
@@ -13054,7 +13054,7 @@
                 </a:solidFill>
                 <a:latin typeface="Calibri"/>
               </a:rPr>
-              <a:t>Inactivity penalty</a:t>
+              <a:t>Expired certs = 0 pts</a:t>
             </a:r>
           </a:p>
           <a:p>
@@ -13065,7 +13065,7 @@
                 </a:solidFill>
                 <a:latin typeface="Calibri"/>
               </a:rPr>
-              <a:t>90+ days idle: -5 pts/month</a:t>
+              <a:t>Renew to restore points</a:t>
             </a:r>
           </a:p>
         </p:txBody>

</xml_diff>